<commit_message>
Sync scripts and translated decks; fix OWASP year to 2025
- Propagate 4 slide edits (title marker, bio, References/Q&A swap,
  footer) into all 6 translated speaker scripts
- Update OWASP Top 10 references 2017 -> 2025 in slides.pptx
- Regenerate all 6 translated decks from current English slides.pptx
- Add apply_translation.py (exact-run-match translation tool)

Co-Authored-By: Claude Opus 4.7 <noreply@anthropic.com>
</commit_message>
<xml_diff>
--- a/slides.pptx
+++ b/slides.pptx
@@ -33950,7 +33950,7 @@
                 <a:uFillTx/>
                 <a:latin typeface="Calibri"/>
               </a:rPr>
-              <a:t>OWASP Top 10 2017: 'Dynamic queries... used directly in the interpreter.'</a:t>
+              <a:t>OWASP Top 10 2025: 'Dynamic queries... used directly in the interpreter.'</a:t>
             </a:r>
             <a:endParaRPr lang="en-US" sz="1600" b="0" u="none" strike="noStrike">
               <a:solidFill>
@@ -39070,7 +39070,7 @@
                 <a:uFillTx/>
                 <a:latin typeface="Calibri"/>
               </a:rPr>
-              <a:t>OWASP 2017 stored-XSS principle — substitute 'admin' with 'LLM'.</a:t>
+              <a:t>OWASP 2025 stored-XSS principle — substitute 'admin' with 'LLM'.</a:t>
             </a:r>
             <a:endParaRPr lang="en-US" sz="1600" b="0" u="none" strike="noStrike">
               <a:solidFill>
@@ -45019,7 +45019,7 @@
                 <a:uFillTx/>
                 <a:latin typeface="Calibri"/>
               </a:rPr>
-              <a:t>OWASP Top 10 — 2017 Edition</a:t>
+              <a:t>OWASP Top 10 — 2025 Edition</a:t>
             </a:r>
             <a:endParaRPr lang="en-US" sz="1600" b="0" u="none" strike="noStrike">
               <a:solidFill>

</xml_diff>

<commit_message>
Rebuild EN narrated + unnarrated videos; add EN narration audio and EN/ES captions
Regenerate slides.mp4 (narrated; long-GOP/CRF28 so the 42-min file stays well
under platform size limits) and slides_presentation.mp4 (45-min, 1 min/slide +
chime) from frames re-rendered after the slide 2 subtitle and slide 38 title
overflow fixes. Refresh slides.pdf to match the corrected slides.pptx. Add EN
per-slide and full narration mp3s, plus slides_en.srt / slides_es.srt caption
tracks (timed to each video) for the YouTube uploads.

Co-Authored-By: Claude <noreply@anthropic.com>
</commit_message>
<xml_diff>
--- a/slides.pptx
+++ b/slides.pptx
@@ -24773,7 +24773,7 @@
               </a:lnSpc>
             </a:pPr>
             <a:r>
-              <a:rPr lang="en-US" sz="3600" b="0" u="none" strike="noStrike">
+              <a:rPr lang="en-US" sz="3250" b="0" u="none" strike="noStrike">
                 <a:solidFill>
                   <a:srgbClr val="FFFFFF"/>
                 </a:solidFill>
@@ -24891,7 +24891,7 @@
           </a:bodyPr>
           <a:p>
             <a:r>
-              <a:rPr lang="en-US" sz="2400" b="0" u="none" strike="noStrike">
+              <a:rPr lang="en-US" sz="2150" b="0" u="none" strike="noStrike">
                 <a:solidFill>
                   <a:srgbClr val="FFFFFF"/>
                 </a:solidFill>
@@ -24961,7 +24961,7 @@
           </a:bodyPr>
           <a:p>
             <a:r>
-              <a:rPr lang="en-US" sz="2400" b="0" u="none" strike="noStrike">
+              <a:rPr lang="en-US" sz="2150" b="0" u="none" strike="noStrike">
                 <a:solidFill>
                   <a:srgbClr val="FFFFFF"/>
                 </a:solidFill>
@@ -25647,7 +25647,7 @@
               </a:lnSpc>
             </a:pPr>
             <a:r>
-              <a:rPr lang="en-US" sz="2000" b="0" u="none" strike="noStrike">
+              <a:rPr lang="en-US" sz="1950" b="0" u="none" strike="noStrike">
                 <a:solidFill>
                   <a:srgbClr val="FFFFFF"/>
                 </a:solidFill>
@@ -25874,7 +25874,7 @@
               </a:lnSpc>
             </a:pPr>
             <a:r>
-              <a:rPr lang="en-US" sz="2000" b="0" u="none" strike="noStrike">
+              <a:rPr lang="en-US" sz="1950" b="0" u="none" strike="noStrike">
                 <a:solidFill>
                   <a:srgbClr val="FFFFFF"/>
                 </a:solidFill>
@@ -31764,7 +31764,7 @@
               </a:lnSpc>
             </a:pPr>
             <a:r>
-              <a:rPr lang="en-US" sz="5400" b="1" u="none" strike="noStrike">
+              <a:rPr lang="en-US" sz="5300" b="1" u="none" strike="noStrike">
                 <a:solidFill>
                   <a:srgbClr val="00FF41"/>
                 </a:solidFill>
@@ -38099,7 +38099,7 @@
               </a:lnSpc>
             </a:pPr>
             <a:r>
-              <a:rPr lang="en-US" sz="4200" b="1" u="none" strike="noStrike">
+              <a:rPr lang="en-US" sz="3800" b="1" u="none" strike="noStrike">
                 <a:solidFill>
                   <a:srgbClr val="FF6B35"/>
                 </a:solidFill>
@@ -39327,7 +39327,7 @@
               </a:lnSpc>
             </a:pPr>
             <a:r>
-              <a:rPr lang="en-US" sz="4200" b="1" u="none" strike="noStrike">
+              <a:rPr lang="en-US" sz="3400" b="1" u="none" strike="noStrike">
                 <a:solidFill>
                   <a:srgbClr val="FF6B35"/>
                 </a:solidFill>
@@ -42602,7 +42602,7 @@
               </a:lnSpc>
             </a:pPr>
             <a:r>
-              <a:rPr lang="en-US" sz="2600" b="1" u="none" strike="noStrike">
+              <a:rPr lang="en-US" sz="2550" b="1" u="none" strike="noStrike">
                 <a:solidFill>
                   <a:srgbClr val="FFFFFF"/>
                 </a:solidFill>
@@ -43778,7 +43778,7 @@
               </a:lnSpc>
             </a:pPr>
             <a:r>
-              <a:rPr lang="en-US" sz="2800" b="1" u="none" strike="noStrike">
+              <a:rPr lang="en-US" sz="2400" b="1" u="none" strike="noStrike">
                 <a:solidFill>
                   <a:srgbClr val="CCCCD6"/>
                 </a:solidFill>
@@ -46224,7 +46224,7 @@
               </a:lnSpc>
             </a:pPr>
             <a:r>
-              <a:rPr lang="en-US" sz="4000" b="1" u="none" strike="noStrike">
+              <a:rPr lang="en-US" sz="3850" b="1" u="none" strike="noStrike">
                 <a:solidFill>
                   <a:srgbClr val="FFFFFF"/>
                 </a:solidFill>
@@ -46338,7 +46338,7 @@
               </a:lnSpc>
             </a:pPr>
             <a:r>
-              <a:rPr lang="en-US" sz="2600" b="1" u="none" strike="noStrike">
+              <a:rPr lang="en-US" sz="2550" b="1" u="none" strike="noStrike">
                 <a:solidFill>
                   <a:srgbClr val="00D4FF"/>
                 </a:solidFill>
@@ -46349,7 +46349,7 @@
               <a:t>▶ </a:t>
             </a:r>
             <a:r>
-              <a:rPr lang="en-US" sz="2600" b="0" u="none" strike="noStrike">
+              <a:rPr lang="en-US" sz="2550" b="0" u="none" strike="noStrike">
                 <a:solidFill>
                   <a:srgbClr val="FFFFFF"/>
                 </a:solidFill>
@@ -46375,7 +46375,7 @@
               </a:lnSpc>
             </a:pPr>
             <a:r>
-              <a:rPr lang="en-US" sz="2600" b="1" u="none" strike="noStrike">
+              <a:rPr lang="en-US" sz="2550" b="1" u="none" strike="noStrike">
                 <a:solidFill>
                   <a:srgbClr val="00D4FF"/>
                 </a:solidFill>
@@ -46386,7 +46386,7 @@
               <a:t>▶ </a:t>
             </a:r>
             <a:r>
-              <a:rPr lang="en-US" sz="2600" b="0" u="none" strike="noStrike">
+              <a:rPr lang="en-US" sz="2550" b="0" u="none" strike="noStrike">
                 <a:solidFill>
                   <a:srgbClr val="FFFFFF"/>
                 </a:solidFill>
@@ -46412,7 +46412,7 @@
               </a:lnSpc>
             </a:pPr>
             <a:r>
-              <a:rPr lang="en-US" sz="2600" b="1" u="none" strike="noStrike">
+              <a:rPr lang="en-US" sz="2550" b="1" u="none" strike="noStrike">
                 <a:solidFill>
                   <a:srgbClr val="00D4FF"/>
                 </a:solidFill>
@@ -46423,7 +46423,7 @@
               <a:t>▶ </a:t>
             </a:r>
             <a:r>
-              <a:rPr lang="en-US" sz="2600" b="0" u="none" strike="noStrike">
+              <a:rPr lang="en-US" sz="2550" b="0" u="none" strike="noStrike">
                 <a:solidFill>
                   <a:srgbClr val="FFFFFF"/>
                 </a:solidFill>
@@ -52670,7 +52670,7 @@
               </a:lnSpc>
             </a:pPr>
             <a:r>
-              <a:rPr lang="en-US" sz="1800" b="0" u="none" strike="noStrike">
+              <a:rPr lang="en-US" sz="1750" b="0" u="none" strike="noStrike">
                 <a:solidFill>
                   <a:srgbClr val="CCCCD6"/>
                 </a:solidFill>

</xml_diff>